<commit_message>
docs: remove platform branding from guide
</commit_message>
<xml_diff>
--- a/Claude_Code_从零到精通_完全指南.pptx
+++ b/Claude_Code_从零到精通_完全指南.pptx
@@ -11302,7 +11302,7 @@
               </a:defRPr>
             </a:pPr>
             <a:r>
-              <a:t>VS Code / JetBrains / WispTerm</a:t>
+              <a:t>VS Code / JetBrains / 本地终端</a:t>
             </a:r>
           </a:p>
         </p:txBody>
@@ -13045,7 +13045,7 @@
               </a:defRPr>
             </a:pPr>
             <a:r>
-              <a:t>VS Code · JetBrains · WispTerm Skill 注册</a:t>
+              <a:t>VS Code · JetBrains · 本地终端 Skill 注册</a:t>
             </a:r>
           </a:p>
         </p:txBody>
@@ -13150,7 +13150,7 @@
               </a:defRPr>
             </a:pPr>
             <a:r>
-              <a:t>🔌 IDE 集成 &amp; WispTerm Skill 注册</a:t>
+              <a:t>🔌 IDE 集成 &amp; 本地终端 Skill 注册</a:t>
             </a:r>
           </a:p>
         </p:txBody>
@@ -13537,7 +13537,7 @@
               </a:defRPr>
             </a:pPr>
             <a:r>
-              <a:t>WispTerm</a:t>
+              <a:t>本地终端</a:t>
             </a:r>
           </a:p>
         </p:txBody>
@@ -13690,7 +13690,7 @@
               </a:defRPr>
             </a:pPr>
             <a:r>
-              <a:t>🏗️ 将 Claude-test Skill 注册到 WispTerm</a:t>
+              <a:t>🏗️ 将 Claude-test Skill 注册到 本地终端</a:t>
             </a:r>
           </a:p>
         </p:txBody>
@@ -13726,7 +13726,7 @@
               </a:defRPr>
             </a:pPr>
             <a:r>
-              <a:t>Windows（便携版）：%USERPROFILE%\.wispterm\skills\claude-test\SKILL.md</a:t>
+              <a:t>Windows（便携版）：%USERPROFILE%\.本地终端\skills\claude-test\SKILL.md</a:t>
             </a:r>
           </a:p>
         </p:txBody>
@@ -13762,7 +13762,7 @@
               </a:defRPr>
             </a:pPr>
             <a:r>
-              <a:t>Windows（安装版）：%APPDATA%\wispterm\skills\claude-test\SKILL.md</a:t>
+              <a:t>Windows（安装版）：%APPDATA%\本地终端\skills\claude-test\SKILL.md</a:t>
             </a:r>
           </a:p>
         </p:txBody>
@@ -13798,7 +13798,7 @@
               </a:defRPr>
             </a:pPr>
             <a:r>
-              <a:t>Linux / WSL：~/.config/wispterm/skills/claude-test/SKILL.md</a:t>
+              <a:t>Linux / WSL：~/.config/本地终端/skills/claude-test/SKILL.md</a:t>
             </a:r>
           </a:p>
         </p:txBody>
@@ -13867,7 +13867,7 @@
               </a:defRPr>
             </a:pPr>
             <a:r>
-              <a:t>→ 注册后在 WispTerm 输入 $claude-test 即可加载此技能</a:t>
+              <a:t>→ 注册后在 本地终端 输入 $claude-test 即可加载此技能</a:t>
             </a:r>
           </a:p>
         </p:txBody>

</xml_diff>